<commit_message>
Rewrite Lecture 6: real CSS alongside the box-model and display screenshots
Most image slides in this deck already had a matching code slide right
before them (margin collapsing, box-sizing comparison, the ul-menu
demo) -- left those as is. Converted the two that were still image-only:
the four-layers box-model diagram and the block/inline/inline-block/none
comparison, each now paired with real CSS matching its screenshot.

Co-Authored-By: Claude Sonnet 5 <noreply@anthropic.com>
</commit_message>
<xml_diff>
--- a/slides/CSC336-Lecture-06-CSS-Box-Model-and-Display.pptx
+++ b/slides/CSC336-Lecture-06-CSS-Box-Model-and-Display.pptx
@@ -4268,12 +4268,156 @@
         </p:nvSpPr>
         <p:spPr>
           <a:xfrm>
-            <a:off x="530352" y="1947672"/>
-            <a:ext cx="11130991" cy="4334256"/>
+            <a:off x="640080" y="1965960"/>
+            <a:ext cx="10911535" cy="1739265"/>
           </a:xfrm>
           <a:prstGeom prst="roundRect">
             <a:avLst>
-              <a:gd name="adj" fmla="val 1266"/>
+              <a:gd name="adj" fmla="val 4206"/>
+            </a:avLst>
+          </a:prstGeom>
+          <a:solidFill>
+            <a:srgbClr val="1E1E4C"/>
+          </a:solidFill>
+          <a:ln/>
+        </p:spPr>
+      </p:sp>
+      <p:sp>
+        <p:nvSpPr>
+          <p:cNvPr id="5" name="Text 3"/>
+          <p:cNvSpPr txBox="1"/>
+          <p:nvPr/>
+        </p:nvSpPr>
+        <p:spPr>
+          <a:xfrm>
+            <a:off x="960120" y="2194560"/>
+            <a:ext cx="10271455" cy="1282065"/>
+          </a:xfrm>
+          <a:prstGeom prst="rect">
+            <a:avLst/>
+          </a:prstGeom>
+          <a:noFill/>
+          <a:ln/>
+        </p:spPr>
+        <p:txBody>
+          <a:bodyPr wrap="square" lIns="0" tIns="0" rIns="0" bIns="0" rtlCol="0" anchor="t"/>
+          <a:lstStyle/>
+          <a:p>
+            <a:pPr indent="0" marL="0">
+              <a:lnSpc>
+                <a:spcPct val="125000"/>
+              </a:lnSpc>
+              <a:buNone/>
+            </a:pPr>
+            <a:r>
+              <a:rPr lang="en-US" sz="1250" dirty="0">
+                <a:solidFill>
+                  <a:srgbClr val="C9D3F5"/>
+                </a:solidFill>
+                <a:latin typeface="Courier New" pitchFamily="34" charset="0"/>
+                <a:ea typeface="Courier New" pitchFamily="34" charset="-122"/>
+                <a:cs typeface="Courier New" pitchFamily="34" charset="-120"/>
+              </a:rPr>
+              <a:t>.section { display: block; }        /* new line, full width  */</a:t>
+            </a:r>
+            <a:endParaRPr lang="en-US" sz="1250" dirty="0"/>
+          </a:p>
+          <a:p>
+            <a:pPr indent="0" marL="0">
+              <a:lnSpc>
+                <a:spcPct val="125000"/>
+              </a:lnSpc>
+              <a:buNone/>
+            </a:pPr>
+            <a:r>
+              <a:rPr lang="en-US" sz="1250" dirty="0">
+                <a:solidFill>
+                  <a:srgbClr val="C9D3F5"/>
+                </a:solidFill>
+                <a:latin typeface="Courier New" pitchFamily="34" charset="0"/>
+                <a:ea typeface="Courier New" pitchFamily="34" charset="-122"/>
+                <a:cs typeface="Courier New" pitchFamily="34" charset="-120"/>
+              </a:rPr>
+              <a:t>.tag     { display: inline; }       /* flows in text, no w/h */</a:t>
+            </a:r>
+            <a:endParaRPr lang="en-US" sz="1250" dirty="0"/>
+          </a:p>
+          <a:p>
+            <a:pPr indent="0" marL="0">
+              <a:lnSpc>
+                <a:spcPct val="125000"/>
+              </a:lnSpc>
+              <a:buNone/>
+            </a:pPr>
+            <a:r>
+              <a:rPr lang="en-US" sz="1250" dirty="0">
+                <a:solidFill>
+                  <a:srgbClr val="C9D3F5"/>
+                </a:solidFill>
+                <a:latin typeface="Courier New" pitchFamily="34" charset="0"/>
+                <a:ea typeface="Courier New" pitchFamily="34" charset="-122"/>
+                <a:cs typeface="Courier New" pitchFamily="34" charset="-120"/>
+              </a:rPr>
+              <a:t>.button  { display: inline-block;   /* inline + respects w/h */</a:t>
+            </a:r>
+            <a:endParaRPr lang="en-US" sz="1250" dirty="0"/>
+          </a:p>
+          <a:p>
+            <a:pPr indent="0" marL="0">
+              <a:lnSpc>
+                <a:spcPct val="125000"/>
+              </a:lnSpc>
+              <a:buNone/>
+            </a:pPr>
+            <a:r>
+              <a:rPr lang="en-US" sz="1250" dirty="0">
+                <a:solidFill>
+                  <a:srgbClr val="C9D3F5"/>
+                </a:solidFill>
+                <a:latin typeface="Courier New" pitchFamily="34" charset="0"/>
+                <a:ea typeface="Courier New" pitchFamily="34" charset="-122"/>
+                <a:cs typeface="Courier New" pitchFamily="34" charset="-120"/>
+              </a:rPr>
+              <a:t>           width: 120px; height: 40px; }</a:t>
+            </a:r>
+            <a:endParaRPr lang="en-US" sz="1250" dirty="0"/>
+          </a:p>
+          <a:p>
+            <a:pPr indent="0" marL="0">
+              <a:lnSpc>
+                <a:spcPct val="125000"/>
+              </a:lnSpc>
+              <a:buNone/>
+            </a:pPr>
+            <a:r>
+              <a:rPr lang="en-US" sz="1250" dirty="0">
+                <a:solidFill>
+                  <a:srgbClr val="C9D3F5"/>
+                </a:solidFill>
+                <a:latin typeface="Courier New" pitchFamily="34" charset="0"/>
+                <a:ea typeface="Courier New" pitchFamily="34" charset="-122"/>
+                <a:cs typeface="Courier New" pitchFamily="34" charset="-120"/>
+              </a:rPr>
+              <a:t>.hidden-panel { display: none; }    /* removed entirely      */</a:t>
+            </a:r>
+            <a:endParaRPr lang="en-US" sz="1250" dirty="0"/>
+          </a:p>
+        </p:txBody>
+      </p:sp>
+      <p:sp>
+        <p:nvSpPr>
+          <p:cNvPr id="6" name="Shape 4"/>
+          <p:cNvSpPr/>
+          <p:nvPr/>
+        </p:nvSpPr>
+        <p:spPr>
+          <a:xfrm>
+            <a:off x="530352" y="3869817"/>
+            <a:ext cx="11130991" cy="2457831"/>
+          </a:xfrm>
+          <a:prstGeom prst="roundRect">
+            <a:avLst>
+              <a:gd name="adj" fmla="val 2232"/>
             </a:avLst>
           </a:prstGeom>
           <a:solidFill>
@@ -4296,7 +4440,7 @@
       </p:sp>
       <p:pic>
         <p:nvPicPr>
-          <p:cNvPr id="5" name="Image 0" descr="D:/GitHub/mern-web-book/docs/assets/img/lecture-06/display-comparison.png">    </p:cNvPr>
+          <p:cNvPr id="7" name="Image 0" descr="D:/GitHub/mern-web-book/docs/assets/img/lecture-06/display-comparison.png">    </p:cNvPr>
           <p:cNvPicPr>
             <a:picLocks noChangeAspect="1"/>
           </p:cNvPicPr>
@@ -4310,8 +4454,8 @@
         </p:blipFill>
         <p:spPr>
           <a:xfrm>
-            <a:off x="3358315" y="2057400"/>
-            <a:ext cx="5475064" cy="4114800"/>
+            <a:off x="4606681" y="3979545"/>
+            <a:ext cx="2978334" cy="2238375"/>
           </a:xfrm>
           <a:prstGeom prst="rect">
             <a:avLst/>
@@ -4320,7 +4464,7 @@
       </p:pic>
       <p:sp>
         <p:nvSpPr>
-          <p:cNvPr id="6" name="Text 3"/>
+          <p:cNvPr id="8" name="Text 5"/>
           <p:cNvSpPr txBox="1"/>
           <p:nvPr/>
         </p:nvSpPr>
@@ -4359,7 +4503,7 @@
       </p:sp>
       <p:sp>
         <p:nvSpPr>
-          <p:cNvPr id="7" name="Text 4"/>
+          <p:cNvPr id="9" name="Text 6"/>
           <p:cNvSpPr txBox="1"/>
           <p:nvPr/>
         </p:nvSpPr>
@@ -4515,11 +4659,11 @@
         <p:spPr>
           <a:xfrm>
             <a:off x="640080" y="1965960"/>
-            <a:ext cx="10911535" cy="1453896"/>
+            <a:ext cx="10911535" cy="1082040"/>
           </a:xfrm>
           <a:prstGeom prst="roundRect">
             <a:avLst>
-              <a:gd name="adj" fmla="val 5031"/>
+              <a:gd name="adj" fmla="val 6761"/>
             </a:avLst>
           </a:prstGeom>
           <a:solidFill>
@@ -4537,7 +4681,7 @@
         <p:spPr>
           <a:xfrm>
             <a:off x="960120" y="2194560"/>
-            <a:ext cx="10271455" cy="996696"/>
+            <a:ext cx="10271455" cy="624840"/>
           </a:xfrm>
           <a:prstGeom prst="rect">
             <a:avLst/>
@@ -4598,8 +4742,8 @@
         </p:nvSpPr>
         <p:spPr>
           <a:xfrm>
-            <a:off x="640080" y="3648456"/>
-            <a:ext cx="10911535" cy="2615184"/>
+            <a:off x="640080" y="3276600"/>
+            <a:ext cx="10911535" cy="2987040"/>
           </a:xfrm>
           <a:prstGeom prst="rect">
             <a:avLst/>
@@ -4826,11 +4970,11 @@
         <p:spPr>
           <a:xfrm>
             <a:off x="640080" y="1965960"/>
-            <a:ext cx="10911535" cy="3291840"/>
+            <a:ext cx="10911535" cy="2415540"/>
           </a:xfrm>
           <a:prstGeom prst="roundRect">
             <a:avLst>
-              <a:gd name="adj" fmla="val 2222"/>
+              <a:gd name="adj" fmla="val 3028"/>
             </a:avLst>
           </a:prstGeom>
           <a:solidFill>
@@ -4848,7 +4992,7 @@
         <p:spPr>
           <a:xfrm>
             <a:off x="960120" y="2194560"/>
-            <a:ext cx="10271455" cy="2834640"/>
+            <a:ext cx="10271455" cy="1958340"/>
           </a:xfrm>
           <a:prstGeom prst="rect">
             <a:avLst/>
@@ -5009,8 +5153,8 @@
         </p:nvSpPr>
         <p:spPr>
           <a:xfrm>
-            <a:off x="640080" y="5486400"/>
-            <a:ext cx="10911535" cy="777240"/>
+            <a:off x="640080" y="4610100"/>
+            <a:ext cx="10911535" cy="1653540"/>
           </a:xfrm>
           <a:prstGeom prst="rect">
             <a:avLst/>
@@ -5237,11 +5381,11 @@
         <p:spPr>
           <a:xfrm>
             <a:off x="640080" y="1965960"/>
-            <a:ext cx="10911535" cy="1453896"/>
+            <a:ext cx="10911535" cy="1082040"/>
           </a:xfrm>
           <a:prstGeom prst="roundRect">
             <a:avLst>
-              <a:gd name="adj" fmla="val 5031"/>
+              <a:gd name="adj" fmla="val 6761"/>
             </a:avLst>
           </a:prstGeom>
           <a:solidFill>
@@ -5259,7 +5403,7 @@
         <p:spPr>
           <a:xfrm>
             <a:off x="960120" y="2194560"/>
-            <a:ext cx="10271455" cy="996696"/>
+            <a:ext cx="10271455" cy="624840"/>
           </a:xfrm>
           <a:prstGeom prst="rect">
             <a:avLst/>
@@ -5320,8 +5464,8 @@
         </p:nvSpPr>
         <p:spPr>
           <a:xfrm>
-            <a:off x="640080" y="3648456"/>
-            <a:ext cx="10911535" cy="2615184"/>
+            <a:off x="640080" y="3276600"/>
+            <a:ext cx="10911535" cy="2987040"/>
           </a:xfrm>
           <a:prstGeom prst="rect">
             <a:avLst/>
@@ -6159,11 +6303,11 @@
         <p:spPr>
           <a:xfrm>
             <a:off x="640080" y="1965960"/>
-            <a:ext cx="10911535" cy="3374136"/>
+            <a:ext cx="10911535" cy="2415540"/>
           </a:xfrm>
           <a:prstGeom prst="roundRect">
             <a:avLst>
-              <a:gd name="adj" fmla="val 2168"/>
+              <a:gd name="adj" fmla="val 3028"/>
             </a:avLst>
           </a:prstGeom>
           <a:solidFill>
@@ -6181,7 +6325,7 @@
         <p:spPr>
           <a:xfrm>
             <a:off x="960120" y="2194560"/>
-            <a:ext cx="10271455" cy="2916936"/>
+            <a:ext cx="10271455" cy="1958340"/>
           </a:xfrm>
           <a:prstGeom prst="rect">
             <a:avLst/>
@@ -9016,12 +9160,136 @@
         </p:nvSpPr>
         <p:spPr>
           <a:xfrm>
-            <a:off x="530352" y="1947672"/>
-            <a:ext cx="11130991" cy="4334256"/>
+            <a:off x="640080" y="1965960"/>
+            <a:ext cx="10911535" cy="1501140"/>
           </a:xfrm>
           <a:prstGeom prst="roundRect">
             <a:avLst>
-              <a:gd name="adj" fmla="val 1266"/>
+              <a:gd name="adj" fmla="val 4873"/>
+            </a:avLst>
+          </a:prstGeom>
+          <a:solidFill>
+            <a:srgbClr val="1E1E4C"/>
+          </a:solidFill>
+          <a:ln/>
+        </p:spPr>
+      </p:sp>
+      <p:sp>
+        <p:nvSpPr>
+          <p:cNvPr id="5" name="Text 3"/>
+          <p:cNvSpPr txBox="1"/>
+          <p:nvPr/>
+        </p:nvSpPr>
+        <p:spPr>
+          <a:xfrm>
+            <a:off x="960120" y="2194560"/>
+            <a:ext cx="10271455" cy="1043940"/>
+          </a:xfrm>
+          <a:prstGeom prst="rect">
+            <a:avLst/>
+          </a:prstGeom>
+          <a:noFill/>
+          <a:ln/>
+        </p:spPr>
+        <p:txBody>
+          <a:bodyPr wrap="square" lIns="0" tIns="0" rIns="0" bIns="0" rtlCol="0" anchor="t"/>
+          <a:lstStyle/>
+          <a:p>
+            <a:pPr indent="0" marL="0">
+              <a:lnSpc>
+                <a:spcPct val="125000"/>
+              </a:lnSpc>
+              <a:buNone/>
+            </a:pPr>
+            <a:r>
+              <a:rPr lang="en-US" sz="1250" dirty="0">
+                <a:solidFill>
+                  <a:srgbClr val="C9D3F5"/>
+                </a:solidFill>
+                <a:latin typeface="Courier New" pitchFamily="34" charset="0"/>
+                <a:ea typeface="Courier New" pitchFamily="34" charset="-122"/>
+                <a:cs typeface="Courier New" pitchFamily="34" charset="-120"/>
+              </a:rPr>
+              <a:t>.content { width: 300px; height: 150px; background: steelblue; }</a:t>
+            </a:r>
+            <a:endParaRPr lang="en-US" sz="1250" dirty="0"/>
+          </a:p>
+          <a:p>
+            <a:pPr indent="0" marL="0">
+              <a:lnSpc>
+                <a:spcPct val="125000"/>
+              </a:lnSpc>
+              <a:buNone/>
+            </a:pPr>
+            <a:r>
+              <a:rPr lang="en-US" sz="1250" dirty="0">
+                <a:solidFill>
+                  <a:srgbClr val="C9D3F5"/>
+                </a:solidFill>
+                <a:latin typeface="Courier New" pitchFamily="34" charset="0"/>
+                <a:ea typeface="Courier New" pitchFamily="34" charset="-122"/>
+                <a:cs typeface="Courier New" pitchFamily="34" charset="-120"/>
+              </a:rPr>
+              <a:t>.padding { padding: 20px; background: seagreen; }</a:t>
+            </a:r>
+            <a:endParaRPr lang="en-US" sz="1250" dirty="0"/>
+          </a:p>
+          <a:p>
+            <a:pPr indent="0" marL="0">
+              <a:lnSpc>
+                <a:spcPct val="125000"/>
+              </a:lnSpc>
+              <a:buNone/>
+            </a:pPr>
+            <a:r>
+              <a:rPr lang="en-US" sz="1250" dirty="0">
+                <a:solidFill>
+                  <a:srgbClr val="C9D3F5"/>
+                </a:solidFill>
+                <a:latin typeface="Courier New" pitchFamily="34" charset="0"/>
+                <a:ea typeface="Courier New" pitchFamily="34" charset="-122"/>
+                <a:cs typeface="Courier New" pitchFamily="34" charset="-120"/>
+              </a:rPr>
+              <a:t>.border  { border: 20px solid darkorange; }</a:t>
+            </a:r>
+            <a:endParaRPr lang="en-US" sz="1250" dirty="0"/>
+          </a:p>
+          <a:p>
+            <a:pPr indent="0" marL="0">
+              <a:lnSpc>
+                <a:spcPct val="125000"/>
+              </a:lnSpc>
+              <a:buNone/>
+            </a:pPr>
+            <a:r>
+              <a:rPr lang="en-US" sz="1250" dirty="0">
+                <a:solidFill>
+                  <a:srgbClr val="C9D3F5"/>
+                </a:solidFill>
+                <a:latin typeface="Courier New" pitchFamily="34" charset="0"/>
+                <a:ea typeface="Courier New" pitchFamily="34" charset="-122"/>
+                <a:cs typeface="Courier New" pitchFamily="34" charset="-120"/>
+              </a:rPr>
+              <a:t>.margin  { margin: 20px; background: wheat; }</a:t>
+            </a:r>
+            <a:endParaRPr lang="en-US" sz="1250" dirty="0"/>
+          </a:p>
+        </p:txBody>
+      </p:sp>
+      <p:sp>
+        <p:nvSpPr>
+          <p:cNvPr id="6" name="Shape 4"/>
+          <p:cNvSpPr/>
+          <p:nvPr/>
+        </p:nvSpPr>
+        <p:spPr>
+          <a:xfrm>
+            <a:off x="530352" y="3631692"/>
+            <a:ext cx="11130991" cy="2695956"/>
+          </a:xfrm>
+          <a:prstGeom prst="roundRect">
+            <a:avLst>
+              <a:gd name="adj" fmla="val 2035"/>
             </a:avLst>
           </a:prstGeom>
           <a:solidFill>
@@ -9044,7 +9312,7 @@
       </p:sp>
       <p:pic>
         <p:nvPicPr>
-          <p:cNvPr id="5" name="Image 0" descr="D:/GitHub/mern-web-book/docs/assets/img/lecture-06/box-model-layers.png">    </p:cNvPr>
+          <p:cNvPr id="7" name="Image 0" descr="D:/GitHub/mern-web-book/docs/assets/img/lecture-06/box-model-layers.png">    </p:cNvPr>
           <p:cNvPicPr>
             <a:picLocks noChangeAspect="1"/>
           </p:cNvPicPr>
@@ -9058,8 +9326,8 @@
         </p:blipFill>
         <p:spPr>
           <a:xfrm>
-            <a:off x="3200248" y="2057400"/>
-            <a:ext cx="5791200" cy="4114800"/>
+            <a:off x="4353125" y="3741420"/>
+            <a:ext cx="3485444" cy="2476500"/>
           </a:xfrm>
           <a:prstGeom prst="rect">
             <a:avLst/>
@@ -9068,7 +9336,7 @@
       </p:pic>
       <p:sp>
         <p:nvSpPr>
-          <p:cNvPr id="6" name="Text 3"/>
+          <p:cNvPr id="8" name="Text 5"/>
           <p:cNvSpPr txBox="1"/>
           <p:nvPr/>
         </p:nvSpPr>
@@ -9107,7 +9375,7 @@
       </p:sp>
       <p:sp>
         <p:nvSpPr>
-          <p:cNvPr id="7" name="Text 4"/>
+          <p:cNvPr id="9" name="Text 6"/>
           <p:cNvSpPr txBox="1"/>
           <p:nvPr/>
         </p:nvSpPr>
@@ -9263,11 +9531,11 @@
         <p:spPr>
           <a:xfrm>
             <a:off x="640080" y="1965960"/>
-            <a:ext cx="10911535" cy="1453896"/>
+            <a:ext cx="10911535" cy="1082040"/>
           </a:xfrm>
           <a:prstGeom prst="roundRect">
             <a:avLst>
-              <a:gd name="adj" fmla="val 5031"/>
+              <a:gd name="adj" fmla="val 6761"/>
             </a:avLst>
           </a:prstGeom>
           <a:solidFill>
@@ -9285,7 +9553,7 @@
         <p:spPr>
           <a:xfrm>
             <a:off x="960120" y="2194560"/>
-            <a:ext cx="10271455" cy="996696"/>
+            <a:ext cx="10271455" cy="624840"/>
           </a:xfrm>
           <a:prstGeom prst="rect">
             <a:avLst/>
@@ -9346,8 +9614,8 @@
         </p:nvSpPr>
         <p:spPr>
           <a:xfrm>
-            <a:off x="640080" y="3648456"/>
-            <a:ext cx="10911535" cy="2615184"/>
+            <a:off x="640080" y="3276600"/>
+            <a:ext cx="10911535" cy="2987040"/>
           </a:xfrm>
           <a:prstGeom prst="rect">
             <a:avLst/>
@@ -10113,11 +10381,11 @@
         <p:spPr>
           <a:xfrm>
             <a:off x="640080" y="1965960"/>
-            <a:ext cx="10911535" cy="3374136"/>
+            <a:ext cx="10911535" cy="2415540"/>
           </a:xfrm>
           <a:prstGeom prst="roundRect">
             <a:avLst>
-              <a:gd name="adj" fmla="val 2168"/>
+              <a:gd name="adj" fmla="val 3028"/>
             </a:avLst>
           </a:prstGeom>
           <a:solidFill>
@@ -10135,7 +10403,7 @@
         <p:spPr>
           <a:xfrm>
             <a:off x="960120" y="2194560"/>
-            <a:ext cx="10271455" cy="2916936"/>
+            <a:ext cx="10271455" cy="1958340"/>
           </a:xfrm>
           <a:prstGeom prst="rect">
             <a:avLst/>

</xml_diff>